<commit_message>
System Design vi: fix review findings on sd-11-028 and sd-11-032
- 028: UUID collision estimate is 9.4e-20, about one in ten quintillion
- 032: HTTP 202 means accepted for processing, not completed or started

Co-Authored-By: Claude Sonnet 5.5 <noreply@anthropic.com>
Claude-Session: https://claude.ai/code/session_01FUEjJx1iJbs8YafmDVXup4
</commit_message>
<xml_diff>
--- a/system-design-101/vi/lessons/sd-11-032/slides/sd-11-032.pptx
+++ b/system-design-101/vi/lessons/sd-11-032/slides/sd-11-032.pptx
@@ -3838,7 +3838,7 @@
               <a:t> 202</a:t>
             </a:r>
             <a:r>
-              <a:rPr lang="en-US" sz="2700" b="1" dirty="0" spc="6" kern="0">
+              <a:rPr lang="en-US" sz="2700" b="1" dirty="0" spc="0" kern="0">
                 <a:solidFill>
                   <a:srgbClr val="14161C"/>
                 </a:solidFill>
@@ -3846,10 +3846,10 @@
                 <a:ea typeface="Be Vietnam Pro" pitchFamily="34" charset="-122"/>
                 <a:cs typeface="Be Vietnam Pro" pitchFamily="34" charset="-120"/>
               </a:rPr>
-              <a:t> "đã</a:t>
-            </a:r>
-            <a:r>
-              <a:rPr lang="en-US" sz="2700" b="1" dirty="0" spc="1" kern="0">
+              <a:t> "chấp nhận,</a:t>
+            </a:r>
+            <a:r>
+              <a:rPr lang="en-US" sz="2700" b="1" dirty="0" spc="11" kern="0">
                 <a:solidFill>
                   <a:srgbClr val="14161C"/>
                 </a:solidFill>
@@ -3857,7 +3857,18 @@
                 <a:ea typeface="Be Vietnam Pro" pitchFamily="34" charset="-122"/>
                 <a:cs typeface="Be Vietnam Pro" pitchFamily="34" charset="-120"/>
               </a:rPr>
-              <a:t> nhận"</a:t>
+              <a:t> chưa</a:t>
+            </a:r>
+            <a:r>
+              <a:rPr lang="en-US" sz="2700" b="1" dirty="0" spc="-20" kern="0">
+                <a:solidFill>
+                  <a:srgbClr val="14161C"/>
+                </a:solidFill>
+                <a:latin typeface="Be Vietnam Pro" pitchFamily="34" charset="0"/>
+                <a:ea typeface="Be Vietnam Pro" pitchFamily="34" charset="-122"/>
+                <a:cs typeface="Be Vietnam Pro" pitchFamily="34" charset="-120"/>
+              </a:rPr>
+              <a:t> xong"</a:t>
             </a:r>
             <a:endParaRPr lang="en-US" sz="2700" dirty="0"/>
           </a:p>
@@ -10648,7 +10659,7 @@
               <a:t> là</a:t>
             </a:r>
             <a:r>
-              <a:rPr lang="en-US" sz="2250" dirty="0" spc="12" kern="0">
+              <a:rPr lang="en-US" sz="2250" dirty="0" spc="2" kern="0">
                 <a:solidFill>
                   <a:srgbClr val="E4E1D8"/>
                 </a:solidFill>
@@ -10656,10 +10667,10 @@
                 <a:ea typeface="Be Vietnam Pro" pitchFamily="34" charset="-122"/>
                 <a:cs typeface="Be Vietnam Pro" pitchFamily="34" charset="-120"/>
               </a:rPr>
-              <a:t> "đã</a:t>
-            </a:r>
-            <a:r>
-              <a:rPr lang="en-US" sz="2250" dirty="0" spc="2" kern="0">
+              <a:t> "chấp</a:t>
+            </a:r>
+            <a:r>
+              <a:rPr lang="en-US" sz="2250" dirty="0" spc="-1" kern="0">
                 <a:solidFill>
                   <a:srgbClr val="E4E1D8"/>
                 </a:solidFill>
@@ -10667,7 +10678,29 @@
                 <a:ea typeface="Be Vietnam Pro" pitchFamily="34" charset="-122"/>
                 <a:cs typeface="Be Vietnam Pro" pitchFamily="34" charset="-120"/>
               </a:rPr>
-              <a:t> nhận".</a:t>
+              <a:t> nhận,</a:t>
+            </a:r>
+            <a:r>
+              <a:rPr lang="en-US" sz="2250" dirty="0" spc="7" kern="0">
+                <a:solidFill>
+                  <a:srgbClr val="E4E1D8"/>
+                </a:solidFill>
+                <a:latin typeface="Be Vietnam Pro" pitchFamily="34" charset="0"/>
+                <a:ea typeface="Be Vietnam Pro" pitchFamily="34" charset="-122"/>
+                <a:cs typeface="Be Vietnam Pro" pitchFamily="34" charset="-120"/>
+              </a:rPr>
+              <a:t> chưa</a:t>
+            </a:r>
+            <a:r>
+              <a:rPr lang="en-US" sz="2250" dirty="0" spc="-10" kern="0">
+                <a:solidFill>
+                  <a:srgbClr val="E4E1D8"/>
+                </a:solidFill>
+                <a:latin typeface="Be Vietnam Pro" pitchFamily="34" charset="0"/>
+                <a:ea typeface="Be Vietnam Pro" pitchFamily="34" charset="-122"/>
+                <a:cs typeface="Be Vietnam Pro" pitchFamily="34" charset="-120"/>
+              </a:rPr>
+              <a:t> xong".</a:t>
             </a:r>
             <a:endParaRPr lang="en-US" sz="2250" dirty="0"/>
           </a:p>

</xml_diff>